<commit_message>
Deck: Aysu portrait on the intro slide, site shots on the title slide, cursor removed from shots
Co-Authored-By: Claude Opus 5.5 <noreply@anthropic.com>
</commit_message>
<xml_diff>
--- a/deck/ChillDesk.pptx
+++ b/deck/ChillDesk.pptx
@@ -1815,7 +1815,7 @@
         <p:spPr>
           <a:xfrm>
             <a:off x="731520" y="2148840"/>
-            <a:ext cx="6583680" cy="1280160"/>
+            <a:ext cx="5394960" cy="1280160"/>
           </a:xfrm>
           <a:prstGeom prst="rect">
             <a:avLst/>
@@ -1854,7 +1854,7 @@
         <p:spPr>
           <a:xfrm>
             <a:off x="731520" y="3429000"/>
-            <a:ext cx="6217920" cy="1097280"/>
+            <a:ext cx="5212080" cy="1097280"/>
           </a:xfrm>
           <a:prstGeom prst="rect">
             <a:avLst/>
@@ -2587,7 +2587,7 @@
         <p:spPr>
           <a:xfrm>
             <a:off x="731520" y="2148840"/>
-            <a:ext cx="6583680" cy="1280160"/>
+            <a:ext cx="5394960" cy="1280160"/>
           </a:xfrm>
           <a:prstGeom prst="rect">
             <a:avLst/>
@@ -2625,7 +2625,7 @@
         <p:spPr>
           <a:xfrm>
             <a:off x="731520" y="3429000"/>
-            <a:ext cx="6217920" cy="1097280"/>
+            <a:ext cx="5212080" cy="1097280"/>
           </a:xfrm>
           <a:prstGeom prst="rect">
             <a:avLst/>
@@ -2818,7 +2818,7 @@
       </p:sp>
       <p:pic>
         <p:nvPicPr>
-          <p:cNvPr id="11" name="anim_phone" descr="/home/ali/Desktop/team-Chill/deck/assets/05-call-aysu-r.png">    </p:cNvPr>
+          <p:cNvPr id="11" name="anim_site" descr="/home/ali/Desktop/team-Chill/deck/assets/01-hero-r.png">    </p:cNvPr>
           <p:cNvPicPr>
             <a:picLocks noChangeAspect="1"/>
           </p:cNvPicPr>
@@ -2832,8 +2832,32 @@
         </p:blipFill>
         <p:spPr>
           <a:xfrm>
-            <a:off x="8001000" y="548640"/>
-            <a:ext cx="3246120" cy="5127049"/>
+            <a:off x="6400800" y="1143000"/>
+            <a:ext cx="5257800" cy="2402979"/>
+          </a:xfrm>
+          <a:prstGeom prst="rect">
+            <a:avLst/>
+          </a:prstGeom>
+        </p:spPr>
+      </p:pic>
+      <p:pic>
+        <p:nvPicPr>
+          <p:cNvPr id="12" name="anim_site2" descr="/home/ali/Desktop/team-Chill/deck/assets/02-products-r.png">    </p:cNvPr>
+          <p:cNvPicPr>
+            <a:picLocks noChangeAspect="1"/>
+          </p:cNvPicPr>
+          <p:nvPr/>
+        </p:nvPicPr>
+        <p:blipFill>
+          <a:blip r:embed="rId4"/>
+          <a:stretch>
+            <a:fillRect/>
+          </a:stretch>
+        </p:blipFill>
+        <p:spPr>
+          <a:xfrm>
+            <a:off x="7589520" y="3520440"/>
+            <a:ext cx="4206240" cy="1922383"/>
           </a:xfrm>
           <a:prstGeom prst="rect">
             <a:avLst/>
@@ -3164,6 +3188,50 @@
                                         <p:cTn id="31" dur="450"/>
                                         <p:tgtEl>
                                           <p:spTgt spid="11"/>
+                                        </p:tgtEl>
+                                      </p:cBhvr>
+                                    </p:animEffect>
+                                  </p:childTnLst>
+                                </p:cTn>
+                              </p:par>
+                            </p:childTnLst>
+                          </p:cTn>
+                        </p:par>
+                        <p:par>
+                          <p:cTn id="32" fill="hold">
+                            <p:stCondLst>
+                              <p:cond delay="630"/>
+                            </p:stCondLst>
+                            <p:childTnLst>
+                              <p:par>
+                                <p:cTn id="33" presetID="10" presetClass="entr" presetSubtype="0" fill="hold" grpId="0" nodeType="withEffect">
+                                  <p:stCondLst>
+                                    <p:cond delay="0"/>
+                                  </p:stCondLst>
+                                  <p:childTnLst>
+                                    <p:set>
+                                      <p:cBhvr>
+                                        <p:cTn id="34" dur="1" fill="hold">
+                                          <p:stCondLst>
+                                            <p:cond delay="0"/>
+                                          </p:stCondLst>
+                                        </p:cTn>
+                                        <p:tgtEl>
+                                          <p:spTgt spid="12"/>
+                                        </p:tgtEl>
+                                        <p:attrNameLst>
+                                          <p:attrName>style.visibility</p:attrName>
+                                        </p:attrNameLst>
+                                      </p:cBhvr>
+                                      <p:to>
+                                        <p:strVal val="visible"/>
+                                      </p:to>
+                                    </p:set>
+                                    <p:animEffect transition="in" filter="fade">
+                                      <p:cBhvr>
+                                        <p:cTn id="35" dur="450"/>
+                                        <p:tgtEl>
+                                          <p:spTgt spid="12"/>
                                         </p:tgtEl>
                                       </p:cBhvr>
                                     </p:animEffect>
@@ -6169,7 +6237,7 @@
         <p:spPr>
           <a:xfrm>
             <a:off x="731520" y="2148840"/>
-            <a:ext cx="6583680" cy="1280160"/>
+            <a:ext cx="5394960" cy="1280160"/>
           </a:xfrm>
           <a:prstGeom prst="rect">
             <a:avLst/>
@@ -6207,7 +6275,7 @@
         <p:spPr>
           <a:xfrm>
             <a:off x="731520" y="3429000"/>
-            <a:ext cx="6217920" cy="1097280"/>
+            <a:ext cx="5212080" cy="1097280"/>
           </a:xfrm>
           <a:prstGeom prst="rect">
             <a:avLst/>
@@ -7032,7 +7100,7 @@
                   <a:schemeClr val="tx1"/>
                 </a:solidFill>
               </a:rPr>
-              <a:t>Söhbətdən sonrakı iş</a:t>
+              <a:t>Əl ilə hesabat</a:t>
             </a:r>
             <a:endParaRPr lang="en-US" sz="2200" dirty="0"/>
           </a:p>
@@ -8442,22 +8510,48 @@
       </p:sp>
       <p:pic>
         <p:nvPicPr>
-          <p:cNvPr id="19" name="anim_hero" descr="/home/ali/Desktop/team-Chill/deck/assets/01-hero-r.png">    </p:cNvPr>
+          <p:cNvPr id="19" name="Image 4" descr="/home/ali/Desktop/team-Chill/deck/assets/ripples-light.png">    </p:cNvPr>
           <p:cNvPicPr>
             <a:picLocks noChangeAspect="1"/>
           </p:cNvPicPr>
           <p:nvPr/>
         </p:nvPicPr>
         <p:blipFill>
-          <a:blip r:embed="rId5"/>
+          <a:blip r:embed="rId5">
+            <a:alphaModFix amt="85000"/>
+          </a:blip>
           <a:stretch>
             <a:fillRect/>
           </a:stretch>
         </p:blipFill>
         <p:spPr>
           <a:xfrm>
-            <a:off x="5806440" y="1508760"/>
-            <a:ext cx="5760720" cy="2632829"/>
+            <a:off x="5989320" y="2377440"/>
+            <a:ext cx="5852160" cy="5852160"/>
+          </a:xfrm>
+          <a:prstGeom prst="rect">
+            <a:avLst/>
+          </a:prstGeom>
+        </p:spPr>
+      </p:pic>
+      <p:pic>
+        <p:nvPicPr>
+          <p:cNvPr id="20" name="anim_aysu" descr="/home/ali/Desktop/team-Chill/deck/assets/07-aysu-portrait-r.png">    </p:cNvPr>
+          <p:cNvPicPr>
+            <a:picLocks noChangeAspect="1"/>
+          </p:cNvPicPr>
+          <p:nvPr/>
+        </p:nvPicPr>
+        <p:blipFill>
+          <a:blip r:embed="rId6"/>
+          <a:stretch>
+            <a:fillRect/>
+          </a:stretch>
+        </p:blipFill>
+        <p:spPr>
+          <a:xfrm>
+            <a:off x="7086600" y="1280160"/>
+            <a:ext cx="3611880" cy="4303517"/>
           </a:xfrm>
           <a:prstGeom prst="rect">
             <a:avLst/>
@@ -8473,14 +8567,48 @@
       </p:pic>
       <p:sp>
         <p:nvSpPr>
-          <p:cNvPr id="20" name="anim_cap"/>
+          <p:cNvPr id="21" name="anim_badge"/>
+          <p:cNvSpPr/>
+          <p:nvPr/>
+        </p:nvSpPr>
+        <p:spPr>
+          <a:xfrm>
+            <a:off x="7315200" y="5532120"/>
+            <a:ext cx="3154680" cy="502920"/>
+          </a:xfrm>
+          <a:prstGeom prst="roundRect">
+            <a:avLst>
+              <a:gd name="adj" fmla="val 49091"/>
+            </a:avLst>
+          </a:prstGeom>
+          <a:solidFill>
+            <a:schemeClr val="bg1"/>
+          </a:solidFill>
+          <a:ln w="12700">
+            <a:solidFill>
+              <a:schemeClr val="accent1"/>
+            </a:solidFill>
+            <a:prstDash val="solid"/>
+          </a:ln>
+          <a:effectLst>
+            <a:outerShdw sx="100000" sy="100000" kx="0" ky="0" algn="bl" rotWithShape="0" blurRad="228600" dist="76200" dir="5400000">
+              <a:srgbClr val="0F2A33">
+                <a:alpha val="18000"/>
+              </a:srgbClr>
+            </a:outerShdw>
+          </a:effectLst>
+        </p:spPr>
+      </p:sp>
+      <p:sp>
+        <p:nvSpPr>
+          <p:cNvPr id="22" name="anim_badget"/>
           <p:cNvSpPr txBox="1"/>
           <p:nvPr/>
         </p:nvSpPr>
         <p:spPr>
           <a:xfrm>
-            <a:off x="5806440" y="4343400"/>
-            <a:ext cx="5760720" cy="320040"/>
+            <a:off x="7315200" y="5532120"/>
+            <a:ext cx="3154680" cy="502920"/>
           </a:xfrm>
           <a:prstGeom prst="rect">
             <a:avLst/>
@@ -8489,21 +8617,32 @@
           <a:ln/>
         </p:spPr>
         <p:txBody>
-          <a:bodyPr wrap="square" lIns="0" tIns="0" rIns="0" bIns="0" rtlCol="0" anchor="t"/>
+          <a:bodyPr wrap="square" lIns="0" tIns="0" rIns="0" bIns="0" rtlCol="0" anchor="ctr"/>
           <a:lstStyle/>
           <a:p>
-            <a:pPr algn="r" indent="0" marL="0">
+            <a:pPr algn="ctr" indent="0" marL="0">
               <a:buNone/>
             </a:pPr>
             <a:r>
-              <a:rPr lang="en-US" sz="1200" dirty="0">
+              <a:rPr lang="en-US" sz="1400" b="1" dirty="0">
+                <a:solidFill>
+                  <a:schemeClr val="accent1"/>
+                </a:solidFill>
+              </a:rPr>
+              <a:t>Aysu</a:t>
+            </a:r>
+            <a:pPr algn="ctr" indent="0" marL="0">
+              <a:buNone/>
+            </a:pPr>
+            <a:r>
+              <a:rPr lang="en-US" sz="1400" dirty="0">
                 <a:solidFill>
                   <a:schemeClr val="accent5"/>
                 </a:solidFill>
               </a:rPr>
-              <a:t>Mallard — Ducktoberfest üçün qurduğumuz demo mağaza</a:t>
+              <a:t>  ·  Mallard dəstək agenti</a:t>
             </a:r>
-            <a:endParaRPr lang="en-US" sz="1200" dirty="0"/>
+            <a:endParaRPr lang="en-US" sz="1400" dirty="0"/>
           </a:p>
         </p:txBody>
       </p:sp>
@@ -9301,7 +9440,7 @@
                                           </p:stCondLst>
                                         </p:cTn>
                                         <p:tgtEl>
-                                          <p:spTgt spid="19"/>
+                                          <p:spTgt spid="20"/>
                                         </p:tgtEl>
                                         <p:attrNameLst>
                                           <p:attrName>style.visibility</p:attrName>
@@ -9315,7 +9454,7 @@
                                       <p:cBhvr>
                                         <p:cTn id="71" dur="450"/>
                                         <p:tgtEl>
-                                          <p:spTgt spid="19"/>
+                                          <p:spTgt spid="20"/>
                                         </p:tgtEl>
                                       </p:cBhvr>
                                     </p:animEffect>
@@ -9345,7 +9484,7 @@
                                           </p:stCondLst>
                                         </p:cTn>
                                         <p:tgtEl>
-                                          <p:spTgt spid="20"/>
+                                          <p:spTgt spid="21"/>
                                         </p:tgtEl>
                                         <p:attrNameLst>
                                           <p:attrName>style.visibility</p:attrName>
@@ -9359,7 +9498,51 @@
                                       <p:cBhvr>
                                         <p:cTn id="75" dur="450"/>
                                         <p:tgtEl>
-                                          <p:spTgt spid="20"/>
+                                          <p:spTgt spid="21"/>
+                                        </p:tgtEl>
+                                      </p:cBhvr>
+                                    </p:animEffect>
+                                  </p:childTnLst>
+                                </p:cTn>
+                              </p:par>
+                            </p:childTnLst>
+                          </p:cTn>
+                        </p:par>
+                        <p:par>
+                          <p:cTn id="76" fill="hold">
+                            <p:stCondLst>
+                              <p:cond delay="1620"/>
+                            </p:stCondLst>
+                            <p:childTnLst>
+                              <p:par>
+                                <p:cTn id="77" presetID="10" presetClass="entr" presetSubtype="0" fill="hold" grpId="0" nodeType="withEffect">
+                                  <p:stCondLst>
+                                    <p:cond delay="0"/>
+                                  </p:stCondLst>
+                                  <p:childTnLst>
+                                    <p:set>
+                                      <p:cBhvr>
+                                        <p:cTn id="78" dur="1" fill="hold">
+                                          <p:stCondLst>
+                                            <p:cond delay="0"/>
+                                          </p:stCondLst>
+                                        </p:cTn>
+                                        <p:tgtEl>
+                                          <p:spTgt spid="22"/>
+                                        </p:tgtEl>
+                                        <p:attrNameLst>
+                                          <p:attrName>style.visibility</p:attrName>
+                                        </p:attrNameLst>
+                                      </p:cBhvr>
+                                      <p:to>
+                                        <p:strVal val="visible"/>
+                                      </p:to>
+                                    </p:set>
+                                    <p:animEffect transition="in" filter="fade">
+                                      <p:cBhvr>
+                                        <p:cTn id="79" dur="450"/>
+                                        <p:tgtEl>
+                                          <p:spTgt spid="22"/>
                                         </p:tgtEl>
                                       </p:cBhvr>
                                     </p:animEffect>
@@ -9402,7 +9585,7 @@
       <p:bldP spid="14" grpId="0"/>
       <p:bldP spid="17" grpId="0"/>
       <p:bldP spid="18" grpId="0"/>
-      <p:bldP spid="20" grpId="0"/>
+      <p:bldP spid="22" grpId="0"/>
     </p:bldLst>
   </p:timing>
 </p:sld>

</xml_diff>

<commit_message>
Fine-tuning results: Gemma 3 1B + LoRA 29.6% -> 61.3% mean accuracy, 100% valid JSON; report, deck results slide, README
Co-Authored-By: Claude Opus 5.5 <noreply@anthropic.com>
</commit_message>
<xml_diff>
--- a/deck/ChillDesk.pptx
+++ b/deck/ChillDesk.pptx
@@ -167,6 +167,208 @@
               <c:strCache>
                 <c:ptCount val="1"/>
                 <c:pt idx="0">
+                  <c:v>Gemma 3 1B (base)</c:v>
+                </c:pt>
+              </c:strCache>
+            </c:strRef>
+          </c:tx>
+          <c:spPr>
+            <a:solidFill>
+              <a:srgbClr val="9AA5A3"/>
+            </a:solidFill>
+            <a:effectLst/>
+          </c:spPr>
+          <c:invertIfNegative val="0"/>
+          <c:dLbls>
+            <c:numFmt formatCode="#,##0" sourceLinked="0"/>
+            <c:txPr>
+              <a:bodyPr/>
+              <a:lstStyle/>
+              <a:p>
+                <a:pPr>
+                  <a:defRPr b="0" i="0" strike="noStrike" sz="1000" u="none">
+                    <a:solidFill>
+                      <a:srgbClr val="10242B"/>
+                    </a:solidFill>
+                    <a:latin typeface="+mn-lt"/>
+                  </a:defRPr>
+                </a:pPr>
+              </a:p>
+            </c:txPr>
+            <c:showLegendKey val="0"/>
+            <c:showVal val="1"/>
+            <c:showCatName val="0"/>
+            <c:showSerName val="0"/>
+            <c:showPercent val="0"/>
+            <c:showBubbleSize val="0"/>
+            <c:showLeaderLines val="0"/>
+          </c:dLbls>
+          <c:cat>
+            <c:multiLvlStrRef>
+              <c:f>Sheet1!$A$2:$A$7</c:f>
+              <c:multiLvlStrCache>
+                <c:ptCount val="6"/>
+                <c:lvl>
+                  <c:pt idx="0">
+                    <c:v>Kateqoriya</c:v>
+                  </c:pt>
+                  <c:pt idx="1">
+                    <c:v>Təcililik</c:v>
+                  </c:pt>
+                  <c:pt idx="2">
+                    <c:v>Emosiya</c:v>
+                  </c:pt>
+                  <c:pt idx="3">
+                    <c:v>Həll olundu</c:v>
+                  </c:pt>
+                  <c:pt idx="4">
+                    <c:v>İnsan lazım</c:v>
+                  </c:pt>
+                  <c:pt idx="5">
+                    <c:v>Komanda</c:v>
+                  </c:pt>
+                </c:lvl>
+              </c:multiLvlStrCache>
+            </c:multiLvlStrRef>
+          </c:cat>
+          <c:val>
+            <c:numRef>
+              <c:f>Sheet1!$B$2:$B$7</c:f>
+              <c:numCache>
+                <c:formatCode>General</c:formatCode>
+                <c:ptCount val="6"/>
+                <c:pt idx="0">
+                  <c:v>0</c:v>
+                </c:pt>
+                <c:pt idx="1">
+                  <c:v>25</c:v>
+                </c:pt>
+                <c:pt idx="2">
+                  <c:v>33</c:v>
+                </c:pt>
+                <c:pt idx="3">
+                  <c:v>45</c:v>
+                </c:pt>
+                <c:pt idx="4">
+                  <c:v>48</c:v>
+                </c:pt>
+                <c:pt idx="5">
+                  <c:v>28</c:v>
+                </c:pt>
+              </c:numCache>
+            </c:numRef>
+          </c:val>
+        </c:ser>
+        <c:ser>
+          <c:idx val="1"/>
+          <c:order val="1"/>
+          <c:tx>
+            <c:strRef>
+              <c:f>Sheet1!$C$1</c:f>
+              <c:strCache>
+                <c:ptCount val="1"/>
+                <c:pt idx="0">
+                  <c:v>Gemma 3 1B + LoRA (bizim)</c:v>
+                </c:pt>
+              </c:strCache>
+            </c:strRef>
+          </c:tx>
+          <c:spPr>
+            <a:solidFill>
+              <a:srgbClr val="0B7A5C"/>
+            </a:solidFill>
+            <a:effectLst/>
+          </c:spPr>
+          <c:invertIfNegative val="0"/>
+          <c:dLbls>
+            <c:numFmt formatCode="#,##0" sourceLinked="0"/>
+            <c:txPr>
+              <a:bodyPr/>
+              <a:lstStyle/>
+              <a:p>
+                <a:pPr>
+                  <a:defRPr b="0" i="0" strike="noStrike" sz="1000" u="none">
+                    <a:solidFill>
+                      <a:srgbClr val="10242B"/>
+                    </a:solidFill>
+                    <a:latin typeface="+mn-lt"/>
+                  </a:defRPr>
+                </a:pPr>
+              </a:p>
+            </c:txPr>
+            <c:showLegendKey val="0"/>
+            <c:showVal val="1"/>
+            <c:showCatName val="0"/>
+            <c:showSerName val="0"/>
+            <c:showPercent val="0"/>
+            <c:showBubbleSize val="0"/>
+            <c:showLeaderLines val="0"/>
+          </c:dLbls>
+          <c:cat>
+            <c:multiLvlStrRef>
+              <c:f>Sheet1!$A$2:$A$7</c:f>
+              <c:multiLvlStrCache>
+                <c:ptCount val="6"/>
+                <c:lvl>
+                  <c:pt idx="0">
+                    <c:v>Kateqoriya</c:v>
+                  </c:pt>
+                  <c:pt idx="1">
+                    <c:v>Təcililik</c:v>
+                  </c:pt>
+                  <c:pt idx="2">
+                    <c:v>Emosiya</c:v>
+                  </c:pt>
+                  <c:pt idx="3">
+                    <c:v>Həll olundu</c:v>
+                  </c:pt>
+                  <c:pt idx="4">
+                    <c:v>İnsan lazım</c:v>
+                  </c:pt>
+                  <c:pt idx="5">
+                    <c:v>Komanda</c:v>
+                  </c:pt>
+                </c:lvl>
+              </c:multiLvlStrCache>
+            </c:multiLvlStrRef>
+          </c:cat>
+          <c:val>
+            <c:numRef>
+              <c:f>Sheet1!$C$2:$C$7</c:f>
+              <c:numCache>
+                <c:formatCode>General</c:formatCode>
+                <c:ptCount val="6"/>
+                <c:pt idx="0">
+                  <c:v>65</c:v>
+                </c:pt>
+                <c:pt idx="1">
+                  <c:v>23</c:v>
+                </c:pt>
+                <c:pt idx="2">
+                  <c:v>73</c:v>
+                </c:pt>
+                <c:pt idx="3">
+                  <c:v>75</c:v>
+                </c:pt>
+                <c:pt idx="4">
+                  <c:v>68</c:v>
+                </c:pt>
+                <c:pt idx="5">
+                  <c:v>65</c:v>
+                </c:pt>
+              </c:numCache>
+            </c:numRef>
+          </c:val>
+        </c:ser>
+        <c:ser>
+          <c:idx val="2"/>
+          <c:order val="2"/>
+          <c:tx>
+            <c:strRef>
+              <c:f>Sheet1!$D$1</c:f>
+              <c:strCache>
+                <c:ptCount val="1"/>
+                <c:pt idx="0">
                   <c:v>Gemma 4 26B (API)</c:v>
                 </c:pt>
               </c:strCache>
@@ -233,7 +435,7 @@
           </c:cat>
           <c:val>
             <c:numRef>
-              <c:f>Sheet1!$B$2:$B$7</c:f>
+              <c:f>Sheet1!$D$2:$D$7</c:f>
               <c:numCache>
                 <c:formatCode>General</c:formatCode>
                 <c:ptCount val="6"/>
@@ -16883,7 +17085,7 @@
                   <a:schemeClr val="accent3"/>
                 </a:solidFill>
               </a:rPr>
-              <a:t>~ dəq</a:t>
+              <a:t>284 s</a:t>
             </a:r>
             <a:endParaRPr lang="en-US" sz="4400" dirty="0"/>
           </a:p>
@@ -18580,7 +18782,7 @@
                   <a:schemeClr val="accent1"/>
                 </a:solidFill>
               </a:rPr>
-              <a:t>…</a:t>
+              <a:t>61</a:t>
             </a:r>
             <a:pPr indent="0" marL="0">
               <a:buNone/>
@@ -18699,7 +18901,7 @@
                   <a:schemeClr val="accent5"/>
                 </a:solidFill>
               </a:rPr>
-              <a:t>…</a:t>
+              <a:t>30</a:t>
             </a:r>
             <a:pPr indent="0" marL="0">
               <a:buNone/>

</xml_diff>